<commit_message>
refactor: update presentation content, group author details, and remove speaker notes in python script
</commit_message>
<xml_diff>
--- a/Diferensiasi_Numerik.pptx
+++ b/Diferensiasi_Numerik.pptx
@@ -6,26 +6,26 @@
   </p:sldMasterIdLst>
   <p:sldIdLst>
     <p:sldId id="256" r:id="rId7"/>
-    <p:sldId id="257" r:id="rId9"/>
-    <p:sldId id="258" r:id="rId10"/>
-    <p:sldId id="259" r:id="rId11"/>
-    <p:sldId id="260" r:id="rId12"/>
-    <p:sldId id="261" r:id="rId13"/>
-    <p:sldId id="262" r:id="rId14"/>
-    <p:sldId id="263" r:id="rId15"/>
-    <p:sldId id="264" r:id="rId16"/>
-    <p:sldId id="265" r:id="rId17"/>
-    <p:sldId id="266" r:id="rId18"/>
-    <p:sldId id="267" r:id="rId19"/>
-    <p:sldId id="268" r:id="rId20"/>
-    <p:sldId id="269" r:id="rId21"/>
-    <p:sldId id="270" r:id="rId22"/>
-    <p:sldId id="271" r:id="rId23"/>
-    <p:sldId id="272" r:id="rId24"/>
-    <p:sldId id="273" r:id="rId25"/>
-    <p:sldId id="274" r:id="rId26"/>
-    <p:sldId id="275" r:id="rId27"/>
-    <p:sldId id="276" r:id="rId28"/>
+    <p:sldId id="257" r:id="rId8"/>
+    <p:sldId id="258" r:id="rId9"/>
+    <p:sldId id="259" r:id="rId10"/>
+    <p:sldId id="260" r:id="rId11"/>
+    <p:sldId id="261" r:id="rId12"/>
+    <p:sldId id="262" r:id="rId13"/>
+    <p:sldId id="263" r:id="rId14"/>
+    <p:sldId id="264" r:id="rId15"/>
+    <p:sldId id="265" r:id="rId16"/>
+    <p:sldId id="266" r:id="rId17"/>
+    <p:sldId id="267" r:id="rId18"/>
+    <p:sldId id="268" r:id="rId19"/>
+    <p:sldId id="269" r:id="rId20"/>
+    <p:sldId id="270" r:id="rId21"/>
+    <p:sldId id="271" r:id="rId22"/>
+    <p:sldId id="272" r:id="rId23"/>
+    <p:sldId id="273" r:id="rId24"/>
+    <p:sldId id="274" r:id="rId25"/>
+    <p:sldId id="275" r:id="rId26"/>
+    <p:sldId id="276" r:id="rId27"/>
   </p:sldIdLst>
   <p:sldSz cx="12191695" cy="6858000" type="screen4x3"/>
   <p:notesSz cx="6858000" cy="9144000"/>
@@ -125,1826 +125,6 @@
     </a:lvl9pPr>
   </p:defaultTextStyle>
 </p:presentation>
-</file>
-
-<file path=ppt/notesMasters/notesMaster1.xml><?xml version="1.0" encoding="utf-8"?>
-<p:notesMaster xmlns:a="http://schemas.openxmlformats.org/drawingml/2006/main" xmlns:p="http://schemas.openxmlformats.org/presentationml/2006/main" xmlns:r="http://schemas.openxmlformats.org/officeDocument/2006/relationships">
-  <p:cSld>
-    <p:bg>
-      <p:bgRef idx="1001">
-        <a:schemeClr val="bg1"/>
-      </p:bgRef>
-    </p:bg>
-    <p:spTree>
-      <p:nvGrpSpPr>
-        <p:cNvPr id="1" name=""/>
-        <p:cNvGrpSpPr/>
-        <p:nvPr/>
-      </p:nvGrpSpPr>
-      <p:grpSpPr>
-        <a:xfrm>
-          <a:off x="0" y="0"/>
-          <a:ext cx="0" cy="0"/>
-          <a:chOff x="0" y="0"/>
-          <a:chExt cx="0" cy="0"/>
-        </a:xfrm>
-      </p:grpSpPr>
-      <p:sp>
-        <p:nvSpPr>
-          <p:cNvPr id="2" name="Header Placeholder 1"/>
-          <p:cNvSpPr>
-            <a:spLocks noGrp="1"/>
-          </p:cNvSpPr>
-          <p:nvPr>
-            <p:ph type="hdr" sz="quarter"/>
-          </p:nvPr>
-        </p:nvSpPr>
-        <p:spPr>
-          <a:xfrm>
-            <a:off x="0" y="0"/>
-            <a:ext cx="2971800" cy="457200"/>
-          </a:xfrm>
-          <a:prstGeom prst="rect">
-            <a:avLst/>
-          </a:prstGeom>
-        </p:spPr>
-        <p:txBody>
-          <a:bodyPr vert="horz" lIns="91440" tIns="45720" rIns="91440" bIns="45720" rtlCol="0"/>
-          <a:lstStyle>
-            <a:lvl1pPr algn="l">
-              <a:defRPr sz="1200"/>
-            </a:lvl1pPr>
-          </a:lstStyle>
-          <a:p>
-            <a:endParaRPr lang="en-US"/>
-          </a:p>
-        </p:txBody>
-      </p:sp>
-      <p:sp>
-        <p:nvSpPr>
-          <p:cNvPr id="3" name="Date Placeholder 2"/>
-          <p:cNvSpPr>
-            <a:spLocks noGrp="1"/>
-          </p:cNvSpPr>
-          <p:nvPr>
-            <p:ph type="dt" idx="1"/>
-          </p:nvPr>
-        </p:nvSpPr>
-        <p:spPr>
-          <a:xfrm>
-            <a:off x="3884613" y="0"/>
-            <a:ext cx="2971800" cy="457200"/>
-          </a:xfrm>
-          <a:prstGeom prst="rect">
-            <a:avLst/>
-          </a:prstGeom>
-        </p:spPr>
-        <p:txBody>
-          <a:bodyPr vert="horz" lIns="91440" tIns="45720" rIns="91440" bIns="45720" rtlCol="0"/>
-          <a:lstStyle>
-            <a:lvl1pPr algn="r">
-              <a:defRPr sz="1200"/>
-            </a:lvl1pPr>
-          </a:lstStyle>
-          <a:p>
-            <a:fld id="{0F89C1C7-3DCD-1040-A9CF-14679D8B5DDD}" type="datetimeFigureOut">
-              <a:rPr lang="en-US" smtClean="0"/>
-              <a:t>10/17/16</a:t>
-            </a:fld>
-            <a:endParaRPr lang="en-US"/>
-          </a:p>
-        </p:txBody>
-      </p:sp>
-      <p:sp>
-        <p:nvSpPr>
-          <p:cNvPr id="4" name="Slide Image Placeholder 3"/>
-          <p:cNvSpPr>
-            <a:spLocks noGrp="1" noRot="1" noChangeAspect="1"/>
-          </p:cNvSpPr>
-          <p:nvPr>
-            <p:ph type="sldImg" idx="2"/>
-          </p:nvPr>
-        </p:nvSpPr>
-        <p:spPr>
-          <a:xfrm>
-            <a:off x="1143000" y="685800"/>
-            <a:ext cx="4572000" cy="3429000"/>
-          </a:xfrm>
-          <a:prstGeom prst="rect">
-            <a:avLst/>
-          </a:prstGeom>
-          <a:noFill/>
-          <a:ln w="12700">
-            <a:solidFill>
-              <a:prstClr val="black"/>
-            </a:solidFill>
-          </a:ln>
-        </p:spPr>
-        <p:txBody>
-          <a:bodyPr vert="horz" lIns="91440" tIns="45720" rIns="91440" bIns="45720" rtlCol="0" anchor="ctr"/>
-          <a:lstStyle/>
-          <a:p>
-            <a:endParaRPr lang="en-US"/>
-          </a:p>
-        </p:txBody>
-      </p:sp>
-      <p:sp>
-        <p:nvSpPr>
-          <p:cNvPr id="5" name="Notes Placeholder 4"/>
-          <p:cNvSpPr>
-            <a:spLocks noGrp="1"/>
-          </p:cNvSpPr>
-          <p:nvPr>
-            <p:ph type="body" sz="quarter" idx="3"/>
-          </p:nvPr>
-        </p:nvSpPr>
-        <p:spPr>
-          <a:xfrm>
-            <a:off x="685800" y="4343400"/>
-            <a:ext cx="5486400" cy="4114800"/>
-          </a:xfrm>
-          <a:prstGeom prst="rect">
-            <a:avLst/>
-          </a:prstGeom>
-        </p:spPr>
-        <p:txBody>
-          <a:bodyPr vert="horz" lIns="91440" tIns="45720" rIns="91440" bIns="45720" rtlCol="0"/>
-          <a:lstStyle/>
-          <a:p>
-            <a:pPr lvl="0"/>
-            <a:r>
-              <a:rPr lang="en-US" smtClean="0"/>
-              <a:t>Click to edit Master text styles</a:t>
-            </a:r>
-          </a:p>
-          <a:p>
-            <a:pPr lvl="1"/>
-            <a:r>
-              <a:rPr lang="en-US" smtClean="0"/>
-              <a:t>Second level</a:t>
-            </a:r>
-          </a:p>
-          <a:p>
-            <a:pPr lvl="2"/>
-            <a:r>
-              <a:rPr lang="en-US" smtClean="0"/>
-              <a:t>Third level</a:t>
-            </a:r>
-          </a:p>
-          <a:p>
-            <a:pPr lvl="3"/>
-            <a:r>
-              <a:rPr lang="en-US" smtClean="0"/>
-              <a:t>Fourth level</a:t>
-            </a:r>
-          </a:p>
-          <a:p>
-            <a:pPr lvl="4"/>
-            <a:r>
-              <a:rPr lang="en-US" smtClean="0"/>
-              <a:t>Fifth level</a:t>
-            </a:r>
-            <a:endParaRPr lang="en-US"/>
-          </a:p>
-        </p:txBody>
-      </p:sp>
-      <p:sp>
-        <p:nvSpPr>
-          <p:cNvPr id="6" name="Footer Placeholder 5"/>
-          <p:cNvSpPr>
-            <a:spLocks noGrp="1"/>
-          </p:cNvSpPr>
-          <p:nvPr>
-            <p:ph type="ftr" sz="quarter" idx="4"/>
-          </p:nvPr>
-        </p:nvSpPr>
-        <p:spPr>
-          <a:xfrm>
-            <a:off x="0" y="8685213"/>
-            <a:ext cx="2971800" cy="457200"/>
-          </a:xfrm>
-          <a:prstGeom prst="rect">
-            <a:avLst/>
-          </a:prstGeom>
-        </p:spPr>
-        <p:txBody>
-          <a:bodyPr vert="horz" lIns="91440" tIns="45720" rIns="91440" bIns="45720" rtlCol="0" anchor="b"/>
-          <a:lstStyle>
-            <a:lvl1pPr algn="l">
-              <a:defRPr sz="1200"/>
-            </a:lvl1pPr>
-          </a:lstStyle>
-          <a:p>
-            <a:endParaRPr lang="en-US"/>
-          </a:p>
-        </p:txBody>
-      </p:sp>
-      <p:sp>
-        <p:nvSpPr>
-          <p:cNvPr id="7" name="Slide Number Placeholder 6"/>
-          <p:cNvSpPr>
-            <a:spLocks noGrp="1"/>
-          </p:cNvSpPr>
-          <p:nvPr>
-            <p:ph type="sldNum" sz="quarter" idx="5"/>
-          </p:nvPr>
-        </p:nvSpPr>
-        <p:spPr>
-          <a:xfrm>
-            <a:off x="3884613" y="8685213"/>
-            <a:ext cx="2971800" cy="457200"/>
-          </a:xfrm>
-          <a:prstGeom prst="rect">
-            <a:avLst/>
-          </a:prstGeom>
-        </p:spPr>
-        <p:txBody>
-          <a:bodyPr vert="horz" lIns="91440" tIns="45720" rIns="91440" bIns="45720" rtlCol="0" anchor="b"/>
-          <a:lstStyle>
-            <a:lvl1pPr algn="r">
-              <a:defRPr sz="1200"/>
-            </a:lvl1pPr>
-          </a:lstStyle>
-          <a:p>
-            <a:fld id="{BB5E49A5-4136-284D-997B-48E1D791AD67}" type="slidenum">
-              <a:rPr lang="en-US" smtClean="0"/>
-              <a:t>‹#›</a:t>
-            </a:fld>
-            <a:endParaRPr lang="en-US"/>
-          </a:p>
-        </p:txBody>
-      </p:sp>
-    </p:spTree>
-    <p:extLst>
-      <p:ext uri="{BB962C8B-B14F-4D97-AF65-F5344CB8AC3E}">
-        <p14:creationId xmlns:p14="http://schemas.microsoft.com/office/powerpoint/2010/main" val="2623252185"/>
-      </p:ext>
-    </p:extLst>
-  </p:cSld>
-  <p:clrMap bg1="lt1" tx1="dk1" bg2="lt2" tx2="dk2" accent1="accent1" accent2="accent2" accent3="accent3" accent4="accent4" accent5="accent5" accent6="accent6" hlink="hlink" folHlink="folHlink"/>
-  <p:notesStyle>
-    <a:lvl1pPr marL="0" algn="l" defTabSz="457200" rtl="0" eaLnBrk="1" latinLnBrk="0" hangingPunct="1">
-      <a:defRPr sz="1200" kern="1200">
-        <a:solidFill>
-          <a:schemeClr val="tx1"/>
-        </a:solidFill>
-        <a:latin typeface="+mn-lt"/>
-        <a:ea typeface="+mn-ea"/>
-        <a:cs typeface="+mn-cs"/>
-      </a:defRPr>
-    </a:lvl1pPr>
-    <a:lvl2pPr marL="457200" algn="l" defTabSz="457200" rtl="0" eaLnBrk="1" latinLnBrk="0" hangingPunct="1">
-      <a:defRPr sz="1200" kern="1200">
-        <a:solidFill>
-          <a:schemeClr val="tx1"/>
-        </a:solidFill>
-        <a:latin typeface="+mn-lt"/>
-        <a:ea typeface="+mn-ea"/>
-        <a:cs typeface="+mn-cs"/>
-      </a:defRPr>
-    </a:lvl2pPr>
-    <a:lvl3pPr marL="914400" algn="l" defTabSz="457200" rtl="0" eaLnBrk="1" latinLnBrk="0" hangingPunct="1">
-      <a:defRPr sz="1200" kern="1200">
-        <a:solidFill>
-          <a:schemeClr val="tx1"/>
-        </a:solidFill>
-        <a:latin typeface="+mn-lt"/>
-        <a:ea typeface="+mn-ea"/>
-        <a:cs typeface="+mn-cs"/>
-      </a:defRPr>
-    </a:lvl3pPr>
-    <a:lvl4pPr marL="1371600" algn="l" defTabSz="457200" rtl="0" eaLnBrk="1" latinLnBrk="0" hangingPunct="1">
-      <a:defRPr sz="1200" kern="1200">
-        <a:solidFill>
-          <a:schemeClr val="tx1"/>
-        </a:solidFill>
-        <a:latin typeface="+mn-lt"/>
-        <a:ea typeface="+mn-ea"/>
-        <a:cs typeface="+mn-cs"/>
-      </a:defRPr>
-    </a:lvl4pPr>
-    <a:lvl5pPr marL="1828800" algn="l" defTabSz="457200" rtl="0" eaLnBrk="1" latinLnBrk="0" hangingPunct="1">
-      <a:defRPr sz="1200" kern="1200">
-        <a:solidFill>
-          <a:schemeClr val="tx1"/>
-        </a:solidFill>
-        <a:latin typeface="+mn-lt"/>
-        <a:ea typeface="+mn-ea"/>
-        <a:cs typeface="+mn-cs"/>
-      </a:defRPr>
-    </a:lvl5pPr>
-    <a:lvl6pPr marL="2286000" algn="l" defTabSz="457200" rtl="0" eaLnBrk="1" latinLnBrk="0" hangingPunct="1">
-      <a:defRPr sz="1200" kern="1200">
-        <a:solidFill>
-          <a:schemeClr val="tx1"/>
-        </a:solidFill>
-        <a:latin typeface="+mn-lt"/>
-        <a:ea typeface="+mn-ea"/>
-        <a:cs typeface="+mn-cs"/>
-      </a:defRPr>
-    </a:lvl6pPr>
-    <a:lvl7pPr marL="2743200" algn="l" defTabSz="457200" rtl="0" eaLnBrk="1" latinLnBrk="0" hangingPunct="1">
-      <a:defRPr sz="1200" kern="1200">
-        <a:solidFill>
-          <a:schemeClr val="tx1"/>
-        </a:solidFill>
-        <a:latin typeface="+mn-lt"/>
-        <a:ea typeface="+mn-ea"/>
-        <a:cs typeface="+mn-cs"/>
-      </a:defRPr>
-    </a:lvl7pPr>
-    <a:lvl8pPr marL="3200400" algn="l" defTabSz="457200" rtl="0" eaLnBrk="1" latinLnBrk="0" hangingPunct="1">
-      <a:defRPr sz="1200" kern="1200">
-        <a:solidFill>
-          <a:schemeClr val="tx1"/>
-        </a:solidFill>
-        <a:latin typeface="+mn-lt"/>
-        <a:ea typeface="+mn-ea"/>
-        <a:cs typeface="+mn-cs"/>
-      </a:defRPr>
-    </a:lvl8pPr>
-    <a:lvl9pPr marL="3657600" algn="l" defTabSz="457200" rtl="0" eaLnBrk="1" latinLnBrk="0" hangingPunct="1">
-      <a:defRPr sz="1200" kern="1200">
-        <a:solidFill>
-          <a:schemeClr val="tx1"/>
-        </a:solidFill>
-        <a:latin typeface="+mn-lt"/>
-        <a:ea typeface="+mn-ea"/>
-        <a:cs typeface="+mn-cs"/>
-      </a:defRPr>
-    </a:lvl9pPr>
-  </p:notesStyle>
-</p:notesMaster>
-</file>
-
-<file path=ppt/notesSlides/notesSlide1.xml><?xml version="1.0" encoding="utf-8"?>
-<p:notes xmlns:a="http://schemas.openxmlformats.org/drawingml/2006/main" xmlns:p="http://schemas.openxmlformats.org/presentationml/2006/main" xmlns:r="http://schemas.openxmlformats.org/officeDocument/2006/relationships">
-  <p:cSld>
-    <p:spTree>
-      <p:nvGrpSpPr>
-        <p:cNvPr id="1" name=""/>
-        <p:cNvGrpSpPr/>
-        <p:nvPr/>
-      </p:nvGrpSpPr>
-      <p:grpSpPr>
-        <a:xfrm>
-          <a:off x="0" y="0"/>
-          <a:ext cx="0" cy="0"/>
-          <a:chOff x="0" y="0"/>
-          <a:chExt cx="0" cy="0"/>
-        </a:xfrm>
-      </p:grpSpPr>
-      <p:sp>
-        <p:nvSpPr>
-          <p:cNvPr id="2" name="Slide Image Placeholder 1"/>
-          <p:cNvSpPr>
-            <a:spLocks noGrp="1"/>
-          </p:cNvSpPr>
-          <p:nvPr>
-            <p:ph type="sldImg" idx="2"/>
-          </p:nvPr>
-        </p:nvSpPr>
-        <p:spPr/>
-      </p:sp>
-      <p:sp>
-        <p:nvSpPr>
-          <p:cNvPr id="3" name="Notes Placeholder 2"/>
-          <p:cNvSpPr>
-            <a:spLocks noGrp="1"/>
-          </p:cNvSpPr>
-          <p:nvPr>
-            <p:ph type="body" idx="3" sz="quarter"/>
-          </p:nvPr>
-        </p:nvSpPr>
-        <p:spPr/>
-        <p:txBody>
-          <a:bodyPr/>
-          <a:lstStyle/>
-          <a:p>
-            <a:r>
-              <a:t>Sapa audiens, sebut judul dan bab. Jelaskan bahwa hari ini kita membahas cara memperkirakan turunan fungsi hanya dari nilai-nilai fungsi. Gambar kurva dengan garis singgung mewakili ide utama: turunan adalah kemiringan garis singgung. Isi placeholder nama, dosen, dan program studi sebelum presentasi.</a:t>
-            </a:r>
-          </a:p>
-        </p:txBody>
-      </p:sp>
-      <p:sp>
-        <p:nvSpPr>
-          <p:cNvPr id="4" name="Slide Number Placeholder 3"/>
-          <p:cNvSpPr>
-            <a:spLocks noGrp="1"/>
-          </p:cNvSpPr>
-          <p:nvPr>
-            <p:ph type="sldNum" idx="5" sz="quarter"/>
-          </p:nvPr>
-        </p:nvSpPr>
-        <p:spPr/>
-      </p:sp>
-    </p:spTree>
-  </p:cSld>
-  <p:clrMapOvr>
-    <a:masterClrMapping/>
-  </p:clrMapOvr>
-</p:notes>
-</file>
-
-<file path=ppt/notesSlides/notesSlide10.xml><?xml version="1.0" encoding="utf-8"?>
-<p:notes xmlns:a="http://schemas.openxmlformats.org/drawingml/2006/main" xmlns:p="http://schemas.openxmlformats.org/presentationml/2006/main" xmlns:r="http://schemas.openxmlformats.org/officeDocument/2006/relationships">
-  <p:cSld>
-    <p:spTree>
-      <p:nvGrpSpPr>
-        <p:cNvPr id="1" name=""/>
-        <p:cNvGrpSpPr/>
-        <p:nvPr/>
-      </p:nvGrpSpPr>
-      <p:grpSpPr>
-        <a:xfrm>
-          <a:off x="0" y="0"/>
-          <a:ext cx="0" cy="0"/>
-          <a:chOff x="0" y="0"/>
-          <a:chExt cx="0" cy="0"/>
-        </a:xfrm>
-      </p:grpSpPr>
-      <p:sp>
-        <p:nvSpPr>
-          <p:cNvPr id="2" name="Slide Image Placeholder 1"/>
-          <p:cNvSpPr>
-            <a:spLocks noGrp="1"/>
-          </p:cNvSpPr>
-          <p:nvPr>
-            <p:ph type="sldImg" idx="2"/>
-          </p:nvPr>
-        </p:nvSpPr>
-        <p:spPr/>
-      </p:sp>
-      <p:sp>
-        <p:nvSpPr>
-          <p:cNvPr id="3" name="Notes Placeholder 2"/>
-          <p:cNvSpPr>
-            <a:spLocks noGrp="1"/>
-          </p:cNvSpPr>
-          <p:nvPr>
-            <p:ph type="body" idx="3" sz="quarter"/>
-          </p:nvPr>
-        </p:nvSpPr>
-        <p:spPr/>
-        <p:txBody>
-          <a:bodyPr/>
-          <a:lstStyle/>
-          <a:p>
-            <a:r>
-              <a:t>Ada dua sumber galat berlawanan: pemotongan (mengecil saat h turun) vs pembulatan/noise (membesar saat h turun). Tabel dihitung sendiri dengan e^x di x=1.</a:t>
-            </a:r>
-          </a:p>
-        </p:txBody>
-      </p:sp>
-      <p:sp>
-        <p:nvSpPr>
-          <p:cNvPr id="4" name="Slide Number Placeholder 3"/>
-          <p:cNvSpPr>
-            <a:spLocks noGrp="1"/>
-          </p:cNvSpPr>
-          <p:nvPr>
-            <p:ph type="sldNum" idx="5" sz="quarter"/>
-          </p:nvPr>
-        </p:nvSpPr>
-        <p:spPr/>
-      </p:sp>
-    </p:spTree>
-  </p:cSld>
-  <p:clrMapOvr>
-    <a:masterClrMapping/>
-  </p:clrMapOvr>
-</p:notes>
-</file>
-
-<file path=ppt/notesSlides/notesSlide11.xml><?xml version="1.0" encoding="utf-8"?>
-<p:notes xmlns:a="http://schemas.openxmlformats.org/drawingml/2006/main" xmlns:p="http://schemas.openxmlformats.org/presentationml/2006/main" xmlns:r="http://schemas.openxmlformats.org/officeDocument/2006/relationships">
-  <p:cSld>
-    <p:spTree>
-      <p:nvGrpSpPr>
-        <p:cNvPr id="1" name=""/>
-        <p:cNvGrpSpPr/>
-        <p:nvPr/>
-      </p:nvGrpSpPr>
-      <p:grpSpPr>
-        <a:xfrm>
-          <a:off x="0" y="0"/>
-          <a:ext cx="0" cy="0"/>
-          <a:chOff x="0" y="0"/>
-          <a:chExt cx="0" cy="0"/>
-        </a:xfrm>
-      </p:grpSpPr>
-      <p:sp>
-        <p:nvSpPr>
-          <p:cNvPr id="2" name="Slide Image Placeholder 1"/>
-          <p:cNvSpPr>
-            <a:spLocks noGrp="1"/>
-          </p:cNvSpPr>
-          <p:nvPr>
-            <p:ph type="sldImg" idx="2"/>
-          </p:nvPr>
-        </p:nvSpPr>
-        <p:spPr/>
-      </p:sp>
-      <p:sp>
-        <p:nvSpPr>
-          <p:cNvPr id="3" name="Notes Placeholder 2"/>
-          <p:cNvSpPr>
-            <a:spLocks noGrp="1"/>
-          </p:cNvSpPr>
-          <p:nvPr>
-            <p:ph type="body" idx="3" sz="quarter"/>
-          </p:nvPr>
-        </p:nvSpPr>
-        <p:spPr/>
-        <p:txBody>
-          <a:bodyPr/>
-          <a:lstStyle/>
-          <a:p>
-            <a:r>
-              <a:t>Slide ini melengkapi slide galat: Ea memberi satuan turunan, Er membandingkan dengan besar turunan, E_% adalah Er x 100. Jika turunan nol, Er tidak terdefinisi.</a:t>
-            </a:r>
-          </a:p>
-        </p:txBody>
-      </p:sp>
-      <p:sp>
-        <p:nvSpPr>
-          <p:cNvPr id="4" name="Slide Number Placeholder 3"/>
-          <p:cNvSpPr>
-            <a:spLocks noGrp="1"/>
-          </p:cNvSpPr>
-          <p:nvPr>
-            <p:ph type="sldNum" idx="5" sz="quarter"/>
-          </p:nvPr>
-        </p:nvSpPr>
-        <p:spPr/>
-      </p:sp>
-    </p:spTree>
-  </p:cSld>
-  <p:clrMapOvr>
-    <a:masterClrMapping/>
-  </p:clrMapOvr>
-</p:notes>
-</file>
-
-<file path=ppt/notesSlides/notesSlide12.xml><?xml version="1.0" encoding="utf-8"?>
-<p:notes xmlns:a="http://schemas.openxmlformats.org/drawingml/2006/main" xmlns:p="http://schemas.openxmlformats.org/presentationml/2006/main" xmlns:r="http://schemas.openxmlformats.org/officeDocument/2006/relationships">
-  <p:cSld>
-    <p:spTree>
-      <p:nvGrpSpPr>
-        <p:cNvPr id="1" name=""/>
-        <p:cNvGrpSpPr/>
-        <p:nvPr/>
-      </p:nvGrpSpPr>
-      <p:grpSpPr>
-        <a:xfrm>
-          <a:off x="0" y="0"/>
-          <a:ext cx="0" cy="0"/>
-          <a:chOff x="0" y="0"/>
-          <a:chExt cx="0" cy="0"/>
-        </a:xfrm>
-      </p:grpSpPr>
-      <p:sp>
-        <p:nvSpPr>
-          <p:cNvPr id="2" name="Slide Image Placeholder 1"/>
-          <p:cNvSpPr>
-            <a:spLocks noGrp="1"/>
-          </p:cNvSpPr>
-          <p:nvPr>
-            <p:ph type="sldImg" idx="2"/>
-          </p:nvPr>
-        </p:nvSpPr>
-        <p:spPr/>
-      </p:sp>
-      <p:sp>
-        <p:nvSpPr>
-          <p:cNvPr id="3" name="Notes Placeholder 2"/>
-          <p:cNvSpPr>
-            <a:spLocks noGrp="1"/>
-          </p:cNvSpPr>
-          <p:nvPr>
-            <p:ph type="body" idx="3" sz="quarter"/>
-          </p:nvPr>
-        </p:nvSpPr>
-        <p:spPr/>
-        <p:txBody>
-          <a:bodyPr/>
-          <a:lstStyle/>
-          <a:p>
-            <a:r>
-              <a:t>Ide Richardson: dua hasil dengan h berbeda digabung agar suku galat utama hilang. Kunci: periksa dulu bentuk galat awalnya, baru pilih rumus.</a:t>
-            </a:r>
-          </a:p>
-        </p:txBody>
-      </p:sp>
-      <p:sp>
-        <p:nvSpPr>
-          <p:cNvPr id="4" name="Slide Number Placeholder 3"/>
-          <p:cNvSpPr>
-            <a:spLocks noGrp="1"/>
-          </p:cNvSpPr>
-          <p:nvPr>
-            <p:ph type="sldNum" idx="5" sz="quarter"/>
-          </p:nvPr>
-        </p:nvSpPr>
-        <p:spPr/>
-      </p:sp>
-    </p:spTree>
-  </p:cSld>
-  <p:clrMapOvr>
-    <a:masterClrMapping/>
-  </p:clrMapOvr>
-</p:notes>
-</file>
-
-<file path=ppt/notesSlides/notesSlide13.xml><?xml version="1.0" encoding="utf-8"?>
-<p:notes xmlns:a="http://schemas.openxmlformats.org/drawingml/2006/main" xmlns:p="http://schemas.openxmlformats.org/presentationml/2006/main" xmlns:r="http://schemas.openxmlformats.org/officeDocument/2006/relationships">
-  <p:cSld>
-    <p:spTree>
-      <p:nvGrpSpPr>
-        <p:cNvPr id="1" name=""/>
-        <p:cNvGrpSpPr/>
-        <p:nvPr/>
-      </p:nvGrpSpPr>
-      <p:grpSpPr>
-        <a:xfrm>
-          <a:off x="0" y="0"/>
-          <a:ext cx="0" cy="0"/>
-          <a:chOff x="0" y="0"/>
-          <a:chExt cx="0" cy="0"/>
-        </a:xfrm>
-      </p:grpSpPr>
-      <p:sp>
-        <p:nvSpPr>
-          <p:cNvPr id="2" name="Slide Image Placeholder 1"/>
-          <p:cNvSpPr>
-            <a:spLocks noGrp="1"/>
-          </p:cNvSpPr>
-          <p:nvPr>
-            <p:ph type="sldImg" idx="2"/>
-          </p:nvPr>
-        </p:nvSpPr>
-        <p:spPr/>
-      </p:sp>
-      <p:sp>
-        <p:nvSpPr>
-          <p:cNvPr id="3" name="Notes Placeholder 2"/>
-          <p:cNvSpPr>
-            <a:spLocks noGrp="1"/>
-          </p:cNvSpPr>
-          <p:nvPr>
-            <p:ph type="body" idx="3" sz="quarter"/>
-          </p:nvPr>
-        </p:nvSpPr>
-        <p:spPr/>
-        <p:txBody>
-          <a:bodyPr/>
-          <a:lstStyle/>
-          <a:p>
-            <a:r>
-              <a:t>Ambil dua hasil dari Slide 8: N₁(0,1) dan N₁(0,05). Karena selisih maju berorde h, pakai N₂ = 2N₁(h/2) - N₁(h). Hasilnya jauh lebih dekat ke nilai eksak.</a:t>
-            </a:r>
-          </a:p>
-        </p:txBody>
-      </p:sp>
-      <p:sp>
-        <p:nvSpPr>
-          <p:cNvPr id="4" name="Slide Number Placeholder 3"/>
-          <p:cNvSpPr>
-            <a:spLocks noGrp="1"/>
-          </p:cNvSpPr>
-          <p:nvPr>
-            <p:ph type="sldNum" idx="5" sz="quarter"/>
-          </p:nvPr>
-        </p:nvSpPr>
-        <p:spPr/>
-      </p:sp>
-    </p:spTree>
-  </p:cSld>
-  <p:clrMapOvr>
-    <a:masterClrMapping/>
-  </p:clrMapOvr>
-</p:notes>
-</file>
-
-<file path=ppt/notesSlides/notesSlide14.xml><?xml version="1.0" encoding="utf-8"?>
-<p:notes xmlns:a="http://schemas.openxmlformats.org/drawingml/2006/main" xmlns:p="http://schemas.openxmlformats.org/presentationml/2006/main" xmlns:r="http://schemas.openxmlformats.org/officeDocument/2006/relationships">
-  <p:cSld>
-    <p:spTree>
-      <p:nvGrpSpPr>
-        <p:cNvPr id="1" name=""/>
-        <p:cNvGrpSpPr/>
-        <p:nvPr/>
-      </p:nvGrpSpPr>
-      <p:grpSpPr>
-        <a:xfrm>
-          <a:off x="0" y="0"/>
-          <a:ext cx="0" cy="0"/>
-          <a:chOff x="0" y="0"/>
-          <a:chExt cx="0" cy="0"/>
-        </a:xfrm>
-      </p:grpSpPr>
-      <p:sp>
-        <p:nvSpPr>
-          <p:cNvPr id="2" name="Slide Image Placeholder 1"/>
-          <p:cNvSpPr>
-            <a:spLocks noGrp="1"/>
-          </p:cNvSpPr>
-          <p:nvPr>
-            <p:ph type="sldImg" idx="2"/>
-          </p:nvPr>
-        </p:nvSpPr>
-        <p:spPr/>
-      </p:sp>
-      <p:sp>
-        <p:nvSpPr>
-          <p:cNvPr id="3" name="Notes Placeholder 2"/>
-          <p:cNvSpPr>
-            <a:spLocks noGrp="1"/>
-          </p:cNvSpPr>
-          <p:nvPr>
-            <p:ph type="body" idx="3" sz="quarter"/>
-          </p:nvPr>
-        </p:nvSpPr>
-        <p:spPr/>
-        <p:txBody>
-          <a:bodyPr/>
-          <a:lstStyle/>
-          <a:p>
-            <a:r>
-              <a:t>Data hanya tabel lima titik. Tiga titik ujung: 22,032310. Tiga titik tengah: 22,228790. Lima titik tengah: 22,166999. Nilai eksak 3e² = 22,167168.</a:t>
-            </a:r>
-          </a:p>
-        </p:txBody>
-      </p:sp>
-      <p:sp>
-        <p:nvSpPr>
-          <p:cNvPr id="4" name="Slide Number Placeholder 3"/>
-          <p:cNvSpPr>
-            <a:spLocks noGrp="1"/>
-          </p:cNvSpPr>
-          <p:nvPr>
-            <p:ph type="sldNum" idx="5" sz="quarter"/>
-          </p:nvPr>
-        </p:nvSpPr>
-        <p:spPr/>
-      </p:sp>
-    </p:spTree>
-  </p:cSld>
-  <p:clrMapOvr>
-    <a:masterClrMapping/>
-  </p:clrMapOvr>
-</p:notes>
-</file>
-
-<file path=ppt/notesSlides/notesSlide15.xml><?xml version="1.0" encoding="utf-8"?>
-<p:notes xmlns:a="http://schemas.openxmlformats.org/drawingml/2006/main" xmlns:p="http://schemas.openxmlformats.org/presentationml/2006/main" xmlns:r="http://schemas.openxmlformats.org/officeDocument/2006/relationships">
-  <p:cSld>
-    <p:spTree>
-      <p:nvGrpSpPr>
-        <p:cNvPr id="1" name=""/>
-        <p:cNvGrpSpPr/>
-        <p:nvPr/>
-      </p:nvGrpSpPr>
-      <p:grpSpPr>
-        <a:xfrm>
-          <a:off x="0" y="0"/>
-          <a:ext cx="0" cy="0"/>
-          <a:chOff x="0" y="0"/>
-          <a:chExt cx="0" cy="0"/>
-        </a:xfrm>
-      </p:grpSpPr>
-      <p:sp>
-        <p:nvSpPr>
-          <p:cNvPr id="2" name="Slide Image Placeholder 1"/>
-          <p:cNvSpPr>
-            <a:spLocks noGrp="1"/>
-          </p:cNvSpPr>
-          <p:nvPr>
-            <p:ph type="sldImg" idx="2"/>
-          </p:nvPr>
-        </p:nvSpPr>
-        <p:spPr/>
-      </p:sp>
-      <p:sp>
-        <p:nvSpPr>
-          <p:cNvPr id="3" name="Notes Placeholder 2"/>
-          <p:cNvSpPr>
-            <a:spLocks noGrp="1"/>
-          </p:cNvSpPr>
-          <p:nvPr>
-            <p:ph type="body" idx="3" sz="quarter"/>
-          </p:nvPr>
-        </p:nvSpPr>
-        <p:spPr/>
-        <p:txBody>
-          <a:bodyPr/>
-          <a:lstStyle/>
-          <a:p>
-            <a:r>
-              <a:t>Di sini diminta melengkapi kolom turunan dari tabel. Di ujung pakai rumus ujung, di tengah pakai rumus tengah. Lima titik tengah hanya bisa untuk x=1,3.</a:t>
-            </a:r>
-          </a:p>
-        </p:txBody>
-      </p:sp>
-      <p:sp>
-        <p:nvSpPr>
-          <p:cNvPr id="4" name="Slide Number Placeholder 3"/>
-          <p:cNvSpPr>
-            <a:spLocks noGrp="1"/>
-          </p:cNvSpPr>
-          <p:nvPr>
-            <p:ph type="sldNum" idx="5" sz="quarter"/>
-          </p:nvPr>
-        </p:nvSpPr>
-        <p:spPr/>
-      </p:sp>
-    </p:spTree>
-  </p:cSld>
-  <p:clrMapOvr>
-    <a:masterClrMapping/>
-  </p:clrMapOvr>
-</p:notes>
-</file>
-
-<file path=ppt/notesSlides/notesSlide16.xml><?xml version="1.0" encoding="utf-8"?>
-<p:notes xmlns:a="http://schemas.openxmlformats.org/drawingml/2006/main" xmlns:p="http://schemas.openxmlformats.org/presentationml/2006/main" xmlns:r="http://schemas.openxmlformats.org/officeDocument/2006/relationships">
-  <p:cSld>
-    <p:spTree>
-      <p:nvGrpSpPr>
-        <p:cNvPr id="1" name=""/>
-        <p:cNvGrpSpPr/>
-        <p:nvPr/>
-      </p:nvGrpSpPr>
-      <p:grpSpPr>
-        <a:xfrm>
-          <a:off x="0" y="0"/>
-          <a:ext cx="0" cy="0"/>
-          <a:chOff x="0" y="0"/>
-          <a:chExt cx="0" cy="0"/>
-        </a:xfrm>
-      </p:grpSpPr>
-      <p:sp>
-        <p:nvSpPr>
-          <p:cNvPr id="2" name="Slide Image Placeholder 1"/>
-          <p:cNvSpPr>
-            <a:spLocks noGrp="1"/>
-          </p:cNvSpPr>
-          <p:nvPr>
-            <p:ph type="sldImg" idx="2"/>
-          </p:nvPr>
-        </p:nvSpPr>
-        <p:spPr/>
-      </p:sp>
-      <p:sp>
-        <p:nvSpPr>
-          <p:cNvPr id="3" name="Notes Placeholder 2"/>
-          <p:cNvSpPr>
-            <a:spLocks noGrp="1"/>
-          </p:cNvSpPr>
-          <p:nvPr>
-            <p:ph type="body" idx="3" sz="quarter"/>
-          </p:nvPr>
-        </p:nvSpPr>
-        <p:spPr/>
-        <p:txBody>
-          <a:bodyPr/>
-          <a:lstStyle/>
-          <a:p>
-            <a:r>
-              <a:t>Rumus tengah punya galat berpangkat genap, jadi dipakai pembagi 3 lalu 15. N₃(0,2) sama dengan nilai eksak sampai 6 angka desimal.</a:t>
-            </a:r>
-          </a:p>
-        </p:txBody>
-      </p:sp>
-      <p:sp>
-        <p:nvSpPr>
-          <p:cNvPr id="4" name="Slide Number Placeholder 3"/>
-          <p:cNvSpPr>
-            <a:spLocks noGrp="1"/>
-          </p:cNvSpPr>
-          <p:nvPr>
-            <p:ph type="sldNum" idx="5" sz="quarter"/>
-          </p:nvPr>
-        </p:nvSpPr>
-        <p:spPr/>
-      </p:sp>
-    </p:spTree>
-  </p:cSld>
-  <p:clrMapOvr>
-    <a:masterClrMapping/>
-  </p:clrMapOvr>
-</p:notes>
-</file>
-
-<file path=ppt/notesSlides/notesSlide17.xml><?xml version="1.0" encoding="utf-8"?>
-<p:notes xmlns:a="http://schemas.openxmlformats.org/drawingml/2006/main" xmlns:p="http://schemas.openxmlformats.org/presentationml/2006/main" xmlns:r="http://schemas.openxmlformats.org/officeDocument/2006/relationships">
-  <p:cSld>
-    <p:spTree>
-      <p:nvGrpSpPr>
-        <p:cNvPr id="1" name=""/>
-        <p:cNvGrpSpPr/>
-        <p:nvPr/>
-      </p:nvGrpSpPr>
-      <p:grpSpPr>
-        <a:xfrm>
-          <a:off x="0" y="0"/>
-          <a:ext cx="0" cy="0"/>
-          <a:chOff x="0" y="0"/>
-          <a:chExt cx="0" cy="0"/>
-        </a:xfrm>
-      </p:grpSpPr>
-      <p:sp>
-        <p:nvSpPr>
-          <p:cNvPr id="2" name="Slide Image Placeholder 1"/>
-          <p:cNvSpPr>
-            <a:spLocks noGrp="1"/>
-          </p:cNvSpPr>
-          <p:nvPr>
-            <p:ph type="sldImg" idx="2"/>
-          </p:nvPr>
-        </p:nvSpPr>
-        <p:spPr/>
-      </p:sp>
-      <p:sp>
-        <p:nvSpPr>
-          <p:cNvPr id="3" name="Notes Placeholder 2"/>
-          <p:cNvSpPr>
-            <a:spLocks noGrp="1"/>
-          </p:cNvSpPr>
-          <p:nvPr>
-            <p:ph type="body" idx="3" sz="quarter"/>
-          </p:nvPr>
-        </p:nvSpPr>
-        <p:spPr/>
-        <p:txBody>
-          <a:bodyPr/>
-          <a:lstStyle/>
-          <a:p>
-            <a:r>
-              <a:t>Titik yang dihitung f'(1,3) dengan h=0,2 dan 0,1. Level ketiga tidak mungkin dihitung karena data di 1,25 dan 1,35 tidak tersedia.</a:t>
-            </a:r>
-          </a:p>
-        </p:txBody>
-      </p:sp>
-      <p:sp>
-        <p:nvSpPr>
-          <p:cNvPr id="4" name="Slide Number Placeholder 3"/>
-          <p:cNvSpPr>
-            <a:spLocks noGrp="1"/>
-          </p:cNvSpPr>
-          <p:nvPr>
-            <p:ph type="sldNum" idx="5" sz="quarter"/>
-          </p:nvPr>
-        </p:nvSpPr>
-        <p:spPr/>
-      </p:sp>
-    </p:spTree>
-  </p:cSld>
-  <p:clrMapOvr>
-    <a:masterClrMapping/>
-  </p:clrMapOvr>
-</p:notes>
-</file>
-
-<file path=ppt/notesSlides/notesSlide18.xml><?xml version="1.0" encoding="utf-8"?>
-<p:notes xmlns:a="http://schemas.openxmlformats.org/drawingml/2006/main" xmlns:p="http://schemas.openxmlformats.org/presentationml/2006/main" xmlns:r="http://schemas.openxmlformats.org/officeDocument/2006/relationships">
-  <p:cSld>
-    <p:spTree>
-      <p:nvGrpSpPr>
-        <p:cNvPr id="1" name=""/>
-        <p:cNvGrpSpPr/>
-        <p:nvPr/>
-      </p:nvGrpSpPr>
-      <p:grpSpPr>
-        <a:xfrm>
-          <a:off x="0" y="0"/>
-          <a:ext cx="0" cy="0"/>
-          <a:chOff x="0" y="0"/>
-          <a:chExt cx="0" cy="0"/>
-        </a:xfrm>
-      </p:grpSpPr>
-      <p:sp>
-        <p:nvSpPr>
-          <p:cNvPr id="2" name="Slide Image Placeholder 1"/>
-          <p:cNvSpPr>
-            <a:spLocks noGrp="1"/>
-          </p:cNvSpPr>
-          <p:nvPr>
-            <p:ph type="sldImg" idx="2"/>
-          </p:nvPr>
-        </p:nvSpPr>
-        <p:spPr/>
-      </p:sp>
-      <p:sp>
-        <p:nvSpPr>
-          <p:cNvPr id="3" name="Notes Placeholder 2"/>
-          <p:cNvSpPr>
-            <a:spLocks noGrp="1"/>
-          </p:cNvSpPr>
-          <p:nvPr>
-            <p:ph type="body" idx="3" sz="quarter"/>
-          </p:nvPr>
-        </p:nvSpPr>
-        <p:spPr/>
-        <p:txBody>
-          <a:bodyPr/>
-          <a:lstStyle/>
-          <a:p>
-            <a:r>
-              <a:t>Gunakan tabel ini untuk merangkum. Maju/mundur O(h), tengah &amp; 3 titik ujung O(h²), lima titik O(h⁴). Richardson memperbaiki hasil rumus lain.</a:t>
-            </a:r>
-          </a:p>
-        </p:txBody>
-      </p:sp>
-      <p:sp>
-        <p:nvSpPr>
-          <p:cNvPr id="4" name="Slide Number Placeholder 3"/>
-          <p:cNvSpPr>
-            <a:spLocks noGrp="1"/>
-          </p:cNvSpPr>
-          <p:nvPr>
-            <p:ph type="sldNum" idx="5" sz="quarter"/>
-          </p:nvPr>
-        </p:nvSpPr>
-        <p:spPr/>
-      </p:sp>
-    </p:spTree>
-  </p:cSld>
-  <p:clrMapOvr>
-    <a:masterClrMapping/>
-  </p:clrMapOvr>
-</p:notes>
-</file>
-
-<file path=ppt/notesSlides/notesSlide19.xml><?xml version="1.0" encoding="utf-8"?>
-<p:notes xmlns:a="http://schemas.openxmlformats.org/drawingml/2006/main" xmlns:p="http://schemas.openxmlformats.org/presentationml/2006/main" xmlns:r="http://schemas.openxmlformats.org/officeDocument/2006/relationships">
-  <p:cSld>
-    <p:spTree>
-      <p:nvGrpSpPr>
-        <p:cNvPr id="1" name=""/>
-        <p:cNvGrpSpPr/>
-        <p:nvPr/>
-      </p:nvGrpSpPr>
-      <p:grpSpPr>
-        <a:xfrm>
-          <a:off x="0" y="0"/>
-          <a:ext cx="0" cy="0"/>
-          <a:chOff x="0" y="0"/>
-          <a:chExt cx="0" cy="0"/>
-        </a:xfrm>
-      </p:grpSpPr>
-      <p:sp>
-        <p:nvSpPr>
-          <p:cNvPr id="2" name="Slide Image Placeholder 1"/>
-          <p:cNvSpPr>
-            <a:spLocks noGrp="1"/>
-          </p:cNvSpPr>
-          <p:nvPr>
-            <p:ph type="sldImg" idx="2"/>
-          </p:nvPr>
-        </p:nvSpPr>
-        <p:spPr/>
-      </p:sp>
-      <p:sp>
-        <p:nvSpPr>
-          <p:cNvPr id="3" name="Notes Placeholder 2"/>
-          <p:cNvSpPr>
-            <a:spLocks noGrp="1"/>
-          </p:cNvSpPr>
-          <p:nvPr>
-            <p:ph type="body" idx="3" sz="quarter"/>
-          </p:nvPr>
-        </p:nvSpPr>
-        <p:spPr/>
-        <p:txBody>
-          <a:bodyPr/>
-          <a:lstStyle/>
-          <a:p>
-            <a:r>
-              <a:t>Slide ini fokus pada kapan rumus dipakai. Pesan penutup: jangan menyimpulkan satu metode selalu paling baik. Lima titik memiliki koefisien besar sehingga lebih sensitif terhadap noise.</a:t>
-            </a:r>
-          </a:p>
-        </p:txBody>
-      </p:sp>
-      <p:sp>
-        <p:nvSpPr>
-          <p:cNvPr id="4" name="Slide Number Placeholder 3"/>
-          <p:cNvSpPr>
-            <a:spLocks noGrp="1"/>
-          </p:cNvSpPr>
-          <p:nvPr>
-            <p:ph type="sldNum" idx="5" sz="quarter"/>
-          </p:nvPr>
-        </p:nvSpPr>
-        <p:spPr/>
-      </p:sp>
-    </p:spTree>
-  </p:cSld>
-  <p:clrMapOvr>
-    <a:masterClrMapping/>
-  </p:clrMapOvr>
-</p:notes>
-</file>
-
-<file path=ppt/notesSlides/notesSlide2.xml><?xml version="1.0" encoding="utf-8"?>
-<p:notes xmlns:a="http://schemas.openxmlformats.org/drawingml/2006/main" xmlns:p="http://schemas.openxmlformats.org/presentationml/2006/main" xmlns:r="http://schemas.openxmlformats.org/officeDocument/2006/relationships">
-  <p:cSld>
-    <p:spTree>
-      <p:nvGrpSpPr>
-        <p:cNvPr id="1" name=""/>
-        <p:cNvGrpSpPr/>
-        <p:nvPr/>
-      </p:nvGrpSpPr>
-      <p:grpSpPr>
-        <a:xfrm>
-          <a:off x="0" y="0"/>
-          <a:ext cx="0" cy="0"/>
-          <a:chOff x="0" y="0"/>
-          <a:chExt cx="0" cy="0"/>
-        </a:xfrm>
-      </p:grpSpPr>
-      <p:sp>
-        <p:nvSpPr>
-          <p:cNvPr id="2" name="Slide Image Placeholder 1"/>
-          <p:cNvSpPr>
-            <a:spLocks noGrp="1"/>
-          </p:cNvSpPr>
-          <p:nvPr>
-            <p:ph type="sldImg" idx="2"/>
-          </p:nvPr>
-        </p:nvSpPr>
-        <p:spPr/>
-      </p:sp>
-      <p:sp>
-        <p:nvSpPr>
-          <p:cNvPr id="3" name="Notes Placeholder 2"/>
-          <p:cNvSpPr>
-            <a:spLocks noGrp="1"/>
-          </p:cNvSpPr>
-          <p:nvPr>
-            <p:ph type="body" idx="3" sz="quarter"/>
-          </p:nvPr>
-        </p:nvSpPr>
-        <p:spPr/>
-        <p:txBody>
-          <a:bodyPr/>
-          <a:lstStyle/>
-          <a:p>
-            <a:r>
-              <a:t>Turunan menyatakan laju perubahan. Kadang fungsi sulit diturunkan, atau kita hanya punya tabel data. Contoh di awal Bab 6 adalah fungsi jarak bola jatuh dengan ln cosh; kecepatannya sulit diturunkan secara analitik. Karena itu kita pakai pendekatan numerik.</a:t>
-            </a:r>
-          </a:p>
-        </p:txBody>
-      </p:sp>
-      <p:sp>
-        <p:nvSpPr>
-          <p:cNvPr id="4" name="Slide Number Placeholder 3"/>
-          <p:cNvSpPr>
-            <a:spLocks noGrp="1"/>
-          </p:cNvSpPr>
-          <p:nvPr>
-            <p:ph type="sldNum" idx="5" sz="quarter"/>
-          </p:nvPr>
-        </p:nvSpPr>
-        <p:spPr/>
-      </p:sp>
-    </p:spTree>
-  </p:cSld>
-  <p:clrMapOvr>
-    <a:masterClrMapping/>
-  </p:clrMapOvr>
-</p:notes>
-</file>
-
-<file path=ppt/notesSlides/notesSlide20.xml><?xml version="1.0" encoding="utf-8"?>
-<p:notes xmlns:a="http://schemas.openxmlformats.org/drawingml/2006/main" xmlns:p="http://schemas.openxmlformats.org/presentationml/2006/main" xmlns:r="http://schemas.openxmlformats.org/officeDocument/2006/relationships">
-  <p:cSld>
-    <p:spTree>
-      <p:nvGrpSpPr>
-        <p:cNvPr id="1" name=""/>
-        <p:cNvGrpSpPr/>
-        <p:nvPr/>
-      </p:nvGrpSpPr>
-      <p:grpSpPr>
-        <a:xfrm>
-          <a:off x="0" y="0"/>
-          <a:ext cx="0" cy="0"/>
-          <a:chOff x="0" y="0"/>
-          <a:chExt cx="0" cy="0"/>
-        </a:xfrm>
-      </p:grpSpPr>
-      <p:sp>
-        <p:nvSpPr>
-          <p:cNvPr id="2" name="Slide Image Placeholder 1"/>
-          <p:cNvSpPr>
-            <a:spLocks noGrp="1"/>
-          </p:cNvSpPr>
-          <p:nvPr>
-            <p:ph type="sldImg" idx="2"/>
-          </p:nvPr>
-        </p:nvSpPr>
-        <p:spPr/>
-      </p:sp>
-      <p:sp>
-        <p:nvSpPr>
-          <p:cNvPr id="3" name="Notes Placeholder 2"/>
-          <p:cNvSpPr>
-            <a:spLocks noGrp="1"/>
-          </p:cNvSpPr>
-          <p:nvPr>
-            <p:ph type="body" idx="3" sz="quarter"/>
-          </p:nvPr>
-        </p:nvSpPr>
-        <p:spPr/>
-        <p:txBody>
-          <a:bodyPr/>
-          <a:lstStyle/>
-          <a:p>
-            <a:r>
-              <a:t>Rangkum perjalanan dari definisi, deret, rumus 2, 3, 5 titik, galat, lalu Richardson. Tutup dengan kutipan penting.</a:t>
-            </a:r>
-          </a:p>
-        </p:txBody>
-      </p:sp>
-      <p:sp>
-        <p:nvSpPr>
-          <p:cNvPr id="4" name="Slide Number Placeholder 3"/>
-          <p:cNvSpPr>
-            <a:spLocks noGrp="1"/>
-          </p:cNvSpPr>
-          <p:nvPr>
-            <p:ph type="sldNum" idx="5" sz="quarter"/>
-          </p:nvPr>
-        </p:nvSpPr>
-        <p:spPr/>
-      </p:sp>
-    </p:spTree>
-  </p:cSld>
-  <p:clrMapOvr>
-    <a:masterClrMapping/>
-  </p:clrMapOvr>
-</p:notes>
-</file>
-
-<file path=ppt/notesSlides/notesSlide21.xml><?xml version="1.0" encoding="utf-8"?>
-<p:notes xmlns:a="http://schemas.openxmlformats.org/drawingml/2006/main" xmlns:p="http://schemas.openxmlformats.org/presentationml/2006/main" xmlns:r="http://schemas.openxmlformats.org/officeDocument/2006/relationships">
-  <p:cSld>
-    <p:spTree>
-      <p:nvGrpSpPr>
-        <p:cNvPr id="1" name=""/>
-        <p:cNvGrpSpPr/>
-        <p:nvPr/>
-      </p:nvGrpSpPr>
-      <p:grpSpPr>
-        <a:xfrm>
-          <a:off x="0" y="0"/>
-          <a:ext cx="0" cy="0"/>
-          <a:chOff x="0" y="0"/>
-          <a:chExt cx="0" cy="0"/>
-        </a:xfrm>
-      </p:grpSpPr>
-      <p:sp>
-        <p:nvSpPr>
-          <p:cNvPr id="2" name="Slide Image Placeholder 1"/>
-          <p:cNvSpPr>
-            <a:spLocks noGrp="1"/>
-          </p:cNvSpPr>
-          <p:nvPr>
-            <p:ph type="sldImg" idx="2"/>
-          </p:nvPr>
-        </p:nvSpPr>
-        <p:spPr/>
-      </p:sp>
-      <p:sp>
-        <p:nvSpPr>
-          <p:cNvPr id="3" name="Notes Placeholder 2"/>
-          <p:cNvSpPr>
-            <a:spLocks noGrp="1"/>
-          </p:cNvSpPr>
-          <p:nvPr>
-            <p:ph type="body" idx="3" sz="quarter"/>
-          </p:nvPr>
-        </p:nvSpPr>
-        <p:spPr/>
-        <p:txBody>
-          <a:bodyPr/>
-          <a:lstStyle/>
-          <a:p>
-            <a:r>
-              <a:t>Sebutkan sumber utama presentasi: buku Metode Numerik karya Imron, Mardlijah, dan Asfihani (2022), Bab 6 Departemen Matematika ITS.</a:t>
-            </a:r>
-          </a:p>
-        </p:txBody>
-      </p:sp>
-      <p:sp>
-        <p:nvSpPr>
-          <p:cNvPr id="4" name="Slide Number Placeholder 3"/>
-          <p:cNvSpPr>
-            <a:spLocks noGrp="1"/>
-          </p:cNvSpPr>
-          <p:nvPr>
-            <p:ph type="sldNum" idx="5" sz="quarter"/>
-          </p:nvPr>
-        </p:nvSpPr>
-        <p:spPr/>
-      </p:sp>
-    </p:spTree>
-  </p:cSld>
-  <p:clrMapOvr>
-    <a:masterClrMapping/>
-  </p:clrMapOvr>
-</p:notes>
-</file>
-
-<file path=ppt/notesSlides/notesSlide3.xml><?xml version="1.0" encoding="utf-8"?>
-<p:notes xmlns:a="http://schemas.openxmlformats.org/drawingml/2006/main" xmlns:p="http://schemas.openxmlformats.org/presentationml/2006/main" xmlns:r="http://schemas.openxmlformats.org/officeDocument/2006/relationships">
-  <p:cSld>
-    <p:spTree>
-      <p:nvGrpSpPr>
-        <p:cNvPr id="1" name=""/>
-        <p:cNvGrpSpPr/>
-        <p:nvPr/>
-      </p:nvGrpSpPr>
-      <p:grpSpPr>
-        <a:xfrm>
-          <a:off x="0" y="0"/>
-          <a:ext cx="0" cy="0"/>
-          <a:chOff x="0" y="0"/>
-          <a:chExt cx="0" cy="0"/>
-        </a:xfrm>
-      </p:grpSpPr>
-      <p:sp>
-        <p:nvSpPr>
-          <p:cNvPr id="2" name="Slide Image Placeholder 1"/>
-          <p:cNvSpPr>
-            <a:spLocks noGrp="1"/>
-          </p:cNvSpPr>
-          <p:nvPr>
-            <p:ph type="sldImg" idx="2"/>
-          </p:nvPr>
-        </p:nvSpPr>
-        <p:spPr/>
-      </p:sp>
-      <p:sp>
-        <p:nvSpPr>
-          <p:cNvPr id="3" name="Notes Placeholder 2"/>
-          <p:cNvSpPr>
-            <a:spLocks noGrp="1"/>
-          </p:cNvSpPr>
-          <p:nvPr>
-            <p:ph type="body" idx="3" sz="quarter"/>
-          </p:nvPr>
-        </p:nvSpPr>
-        <p:spPr/>
-        <p:txBody>
-          <a:bodyPr/>
-          <a:lstStyle/>
-          <a:p>
-            <a:r>
-              <a:t>Slide ini penjelasan tambahan agar audiens tahu untuk apa rumus Bab 6 dipakai. Datanya sengaja dibuat sederhana dari s(t) = t^3 supaya kita tahu jawaban benarnya (12 m/s).</a:t>
-            </a:r>
-          </a:p>
-        </p:txBody>
-      </p:sp>
-      <p:sp>
-        <p:nvSpPr>
-          <p:cNvPr id="4" name="Slide Number Placeholder 3"/>
-          <p:cNvSpPr>
-            <a:spLocks noGrp="1"/>
-          </p:cNvSpPr>
-          <p:nvPr>
-            <p:ph type="sldNum" idx="5" sz="quarter"/>
-          </p:nvPr>
-        </p:nvSpPr>
-        <p:spPr/>
-      </p:sp>
-    </p:spTree>
-  </p:cSld>
-  <p:clrMapOvr>
-    <a:masterClrMapping/>
-  </p:clrMapOvr>
-</p:notes>
-</file>
-
-<file path=ppt/notesSlides/notesSlide4.xml><?xml version="1.0" encoding="utf-8"?>
-<p:notes xmlns:a="http://schemas.openxmlformats.org/drawingml/2006/main" xmlns:p="http://schemas.openxmlformats.org/presentationml/2006/main" xmlns:r="http://schemas.openxmlformats.org/officeDocument/2006/relationships">
-  <p:cSld>
-    <p:spTree>
-      <p:nvGrpSpPr>
-        <p:cNvPr id="1" name=""/>
-        <p:cNvGrpSpPr/>
-        <p:nvPr/>
-      </p:nvGrpSpPr>
-      <p:grpSpPr>
-        <a:xfrm>
-          <a:off x="0" y="0"/>
-          <a:ext cx="0" cy="0"/>
-          <a:chOff x="0" y="0"/>
-          <a:chExt cx="0" cy="0"/>
-        </a:xfrm>
-      </p:grpSpPr>
-      <p:sp>
-        <p:nvSpPr>
-          <p:cNvPr id="2" name="Slide Image Placeholder 1"/>
-          <p:cNvSpPr>
-            <a:spLocks noGrp="1"/>
-          </p:cNvSpPr>
-          <p:nvPr>
-            <p:ph type="sldImg" idx="2"/>
-          </p:nvPr>
-        </p:nvSpPr>
-        <p:spPr/>
-      </p:sp>
-      <p:sp>
-        <p:nvSpPr>
-          <p:cNvPr id="3" name="Notes Placeholder 2"/>
-          <p:cNvSpPr>
-            <a:spLocks noGrp="1"/>
-          </p:cNvSpPr>
-          <p:nvPr>
-            <p:ph type="body" idx="3" sz="quarter"/>
-          </p:nvPr>
-        </p:nvSpPr>
-        <p:spPr/>
-        <p:txBody>
-          <a:bodyPr/>
-          <a:lstStyle/>
-          <a:p>
-            <a:r>
-              <a:t>Buku menurunkan rumus lewat polinomial Lagrange dan suku galatnya, bukan langsung lewat Taylor. Intinya: fungsi didekati dengan polinomial yang melalui titik data, lalu diturunkan.</a:t>
-            </a:r>
-          </a:p>
-        </p:txBody>
-      </p:sp>
-      <p:sp>
-        <p:nvSpPr>
-          <p:cNvPr id="4" name="Slide Number Placeholder 3"/>
-          <p:cNvSpPr>
-            <a:spLocks noGrp="1"/>
-          </p:cNvSpPr>
-          <p:nvPr>
-            <p:ph type="sldNum" idx="5" sz="quarter"/>
-          </p:nvPr>
-        </p:nvSpPr>
-        <p:spPr/>
-      </p:sp>
-    </p:spTree>
-  </p:cSld>
-  <p:clrMapOvr>
-    <a:masterClrMapping/>
-  </p:clrMapOvr>
-</p:notes>
-</file>
-
-<file path=ppt/notesSlides/notesSlide5.xml><?xml version="1.0" encoding="utf-8"?>
-<p:notes xmlns:a="http://schemas.openxmlformats.org/drawingml/2006/main" xmlns:p="http://schemas.openxmlformats.org/presentationml/2006/main" xmlns:r="http://schemas.openxmlformats.org/officeDocument/2006/relationships">
-  <p:cSld>
-    <p:spTree>
-      <p:nvGrpSpPr>
-        <p:cNvPr id="1" name=""/>
-        <p:cNvGrpSpPr/>
-        <p:nvPr/>
-      </p:nvGrpSpPr>
-      <p:grpSpPr>
-        <a:xfrm>
-          <a:off x="0" y="0"/>
-          <a:ext cx="0" cy="0"/>
-          <a:chOff x="0" y="0"/>
-          <a:chExt cx="0" cy="0"/>
-        </a:xfrm>
-      </p:grpSpPr>
-      <p:sp>
-        <p:nvSpPr>
-          <p:cNvPr id="2" name="Slide Image Placeholder 1"/>
-          <p:cNvSpPr>
-            <a:spLocks noGrp="1"/>
-          </p:cNvSpPr>
-          <p:nvPr>
-            <p:ph type="sldImg" idx="2"/>
-          </p:nvPr>
-        </p:nvSpPr>
-        <p:spPr/>
-      </p:sp>
-      <p:sp>
-        <p:nvSpPr>
-          <p:cNvPr id="3" name="Notes Placeholder 2"/>
-          <p:cNvSpPr>
-            <a:spLocks noGrp="1"/>
-          </p:cNvSpPr>
-          <p:nvPr>
-            <p:ph type="body" idx="3" sz="quarter"/>
-          </p:nvPr>
-        </p:nvSpPr>
-        <p:spPr/>
-        <p:txBody>
-          <a:bodyPr/>
-          <a:lstStyle/>
-          <a:p>
-            <a:r>
-              <a:t>Dua rumus ini adalah yang paling sederhana. Maju memakai titik di depan, mundur memakai titik di belakang. Keduanya hanya butuh dua nilai fungsi dan galatnya berorde h.</a:t>
-            </a:r>
-          </a:p>
-        </p:txBody>
-      </p:sp>
-      <p:sp>
-        <p:nvSpPr>
-          <p:cNvPr id="4" name="Slide Number Placeholder 3"/>
-          <p:cNvSpPr>
-            <a:spLocks noGrp="1"/>
-          </p:cNvSpPr>
-          <p:nvPr>
-            <p:ph type="sldNum" idx="5" sz="quarter"/>
-          </p:nvPr>
-        </p:nvSpPr>
-        <p:spPr/>
-      </p:sp>
-    </p:spTree>
-  </p:cSld>
-  <p:clrMapOvr>
-    <a:masterClrMapping/>
-  </p:clrMapOvr>
-</p:notes>
-</file>
-
-<file path=ppt/notesSlides/notesSlide6.xml><?xml version="1.0" encoding="utf-8"?>
-<p:notes xmlns:a="http://schemas.openxmlformats.org/drawingml/2006/main" xmlns:p="http://schemas.openxmlformats.org/presentationml/2006/main" xmlns:r="http://schemas.openxmlformats.org/officeDocument/2006/relationships">
-  <p:cSld>
-    <p:spTree>
-      <p:nvGrpSpPr>
-        <p:cNvPr id="1" name=""/>
-        <p:cNvGrpSpPr/>
-        <p:nvPr/>
-      </p:nvGrpSpPr>
-      <p:grpSpPr>
-        <a:xfrm>
-          <a:off x="0" y="0"/>
-          <a:ext cx="0" cy="0"/>
-          <a:chOff x="0" y="0"/>
-          <a:chExt cx="0" cy="0"/>
-        </a:xfrm>
-      </p:grpSpPr>
-      <p:sp>
-        <p:nvSpPr>
-          <p:cNvPr id="2" name="Slide Image Placeholder 1"/>
-          <p:cNvSpPr>
-            <a:spLocks noGrp="1"/>
-          </p:cNvSpPr>
-          <p:nvPr>
-            <p:ph type="sldImg" idx="2"/>
-          </p:nvPr>
-        </p:nvSpPr>
-        <p:spPr/>
-      </p:sp>
-      <p:sp>
-        <p:nvSpPr>
-          <p:cNvPr id="3" name="Notes Placeholder 2"/>
-          <p:cNvSpPr>
-            <a:spLocks noGrp="1"/>
-          </p:cNvSpPr>
-          <p:nvPr>
-            <p:ph type="body" idx="3" sz="quarter"/>
-          </p:nvPr>
-        </p:nvSpPr>
-        <p:spPr/>
-        <p:txBody>
-          <a:bodyPr/>
-          <a:lstStyle/>
-          <a:p>
-            <a:r>
-              <a:t>Selisih tengah adalah rumus tiga titik tengah di buku (6.5), tanpa memakai f(x₀) itu sendiri. Karena simetris, suku galat orde pertama saling meniadakan, sehingga galatnya berorde h².</a:t>
-            </a:r>
-          </a:p>
-        </p:txBody>
-      </p:sp>
-      <p:sp>
-        <p:nvSpPr>
-          <p:cNvPr id="4" name="Slide Number Placeholder 3"/>
-          <p:cNvSpPr>
-            <a:spLocks noGrp="1"/>
-          </p:cNvSpPr>
-          <p:nvPr>
-            <p:ph type="sldNum" idx="5" sz="quarter"/>
-          </p:nvPr>
-        </p:nvSpPr>
-        <p:spPr/>
-      </p:sp>
-    </p:spTree>
-  </p:cSld>
-  <p:clrMapOvr>
-    <a:masterClrMapping/>
-  </p:clrMapOvr>
-</p:notes>
-</file>
-
-<file path=ppt/notesSlides/notesSlide7.xml><?xml version="1.0" encoding="utf-8"?>
-<p:notes xmlns:a="http://schemas.openxmlformats.org/drawingml/2006/main" xmlns:p="http://schemas.openxmlformats.org/presentationml/2006/main" xmlns:r="http://schemas.openxmlformats.org/officeDocument/2006/relationships">
-  <p:cSld>
-    <p:spTree>
-      <p:nvGrpSpPr>
-        <p:cNvPr id="1" name=""/>
-        <p:cNvGrpSpPr/>
-        <p:nvPr/>
-      </p:nvGrpSpPr>
-      <p:grpSpPr>
-        <a:xfrm>
-          <a:off x="0" y="0"/>
-          <a:ext cx="0" cy="0"/>
-          <a:chOff x="0" y="0"/>
-          <a:chExt cx="0" cy="0"/>
-        </a:xfrm>
-      </p:grpSpPr>
-      <p:sp>
-        <p:nvSpPr>
-          <p:cNvPr id="2" name="Slide Image Placeholder 1"/>
-          <p:cNvSpPr>
-            <a:spLocks noGrp="1"/>
-          </p:cNvSpPr>
-          <p:nvPr>
-            <p:ph type="sldImg" idx="2"/>
-          </p:nvPr>
-        </p:nvSpPr>
-        <p:spPr/>
-      </p:sp>
-      <p:sp>
-        <p:nvSpPr>
-          <p:cNvPr id="3" name="Notes Placeholder 2"/>
-          <p:cNvSpPr>
-            <a:spLocks noGrp="1"/>
-          </p:cNvSpPr>
-          <p:nvPr>
-            <p:ph type="body" idx="3" sz="quarter"/>
-          </p:nvPr>
-        </p:nvSpPr>
-        <p:spPr/>
-        <p:txBody>
-          <a:bodyPr/>
-          <a:lstStyle/>
-          <a:p>
-            <a:r>
-              <a:t>Rumus tiga titik ujung dipakai saat titik ada di ujung data. Rumus lima titik tengah memakai koefisien 1, -8, 8, -1 dan penyebut 12h; galatnya berorde h⁴.</a:t>
-            </a:r>
-          </a:p>
-        </p:txBody>
-      </p:sp>
-      <p:sp>
-        <p:nvSpPr>
-          <p:cNvPr id="4" name="Slide Number Placeholder 3"/>
-          <p:cNvSpPr>
-            <a:spLocks noGrp="1"/>
-          </p:cNvSpPr>
-          <p:nvPr>
-            <p:ph type="sldNum" idx="5" sz="quarter"/>
-          </p:nvPr>
-        </p:nvSpPr>
-        <p:spPr/>
-      </p:sp>
-    </p:spTree>
-  </p:cSld>
-  <p:clrMapOvr>
-    <a:masterClrMapping/>
-  </p:clrMapOvr>
-</p:notes>
-</file>
-
-<file path=ppt/notesSlides/notesSlide8.xml><?xml version="1.0" encoding="utf-8"?>
-<p:notes xmlns:a="http://schemas.openxmlformats.org/drawingml/2006/main" xmlns:p="http://schemas.openxmlformats.org/presentationml/2006/main" xmlns:r="http://schemas.openxmlformats.org/officeDocument/2006/relationships">
-  <p:cSld>
-    <p:spTree>
-      <p:nvGrpSpPr>
-        <p:cNvPr id="1" name=""/>
-        <p:cNvGrpSpPr/>
-        <p:nvPr/>
-      </p:nvGrpSpPr>
-      <p:grpSpPr>
-        <a:xfrm>
-          <a:off x="0" y="0"/>
-          <a:ext cx="0" cy="0"/>
-          <a:chOff x="0" y="0"/>
-          <a:chExt cx="0" cy="0"/>
-        </a:xfrm>
-      </p:grpSpPr>
-      <p:sp>
-        <p:nvSpPr>
-          <p:cNvPr id="2" name="Slide Image Placeholder 1"/>
-          <p:cNvSpPr>
-            <a:spLocks noGrp="1"/>
-          </p:cNvSpPr>
-          <p:nvPr>
-            <p:ph type="sldImg" idx="2"/>
-          </p:nvPr>
-        </p:nvSpPr>
-        <p:spPr/>
-      </p:sp>
-      <p:sp>
-        <p:nvSpPr>
-          <p:cNvPr id="3" name="Notes Placeholder 2"/>
-          <p:cNvSpPr>
-            <a:spLocks noGrp="1"/>
-          </p:cNvSpPr>
-          <p:nvPr>
-            <p:ph type="body" idx="3" sz="quarter"/>
-          </p:nvPr>
-        </p:nvSpPr>
-        <p:spPr/>
-        <p:txBody>
-          <a:bodyPr/>
-          <a:lstStyle/>
-          <a:p>
-            <a:r>
-              <a:t>Substitusikan x₀ = 1,8 dan h = 0,1 ke rumus beda maju: ln 1,9 dikurangi ln 1,8, dibagi 0,1, hasilnya 0,5406722. Bandingkan dengan eksak 1/1,8 = 0,5555556.</a:t>
-            </a:r>
-          </a:p>
-        </p:txBody>
-      </p:sp>
-      <p:sp>
-        <p:nvSpPr>
-          <p:cNvPr id="4" name="Slide Number Placeholder 3"/>
-          <p:cNvSpPr>
-            <a:spLocks noGrp="1"/>
-          </p:cNvSpPr>
-          <p:nvPr>
-            <p:ph type="sldNum" idx="5" sz="quarter"/>
-          </p:nvPr>
-        </p:nvSpPr>
-        <p:spPr/>
-      </p:sp>
-    </p:spTree>
-  </p:cSld>
-  <p:clrMapOvr>
-    <a:masterClrMapping/>
-  </p:clrMapOvr>
-</p:notes>
-</file>
-
-<file path=ppt/notesSlides/notesSlide9.xml><?xml version="1.0" encoding="utf-8"?>
-<p:notes xmlns:a="http://schemas.openxmlformats.org/drawingml/2006/main" xmlns:p="http://schemas.openxmlformats.org/presentationml/2006/main" xmlns:r="http://schemas.openxmlformats.org/officeDocument/2006/relationships">
-  <p:cSld>
-    <p:spTree>
-      <p:nvGrpSpPr>
-        <p:cNvPr id="1" name=""/>
-        <p:cNvGrpSpPr/>
-        <p:nvPr/>
-      </p:nvGrpSpPr>
-      <p:grpSpPr>
-        <a:xfrm>
-          <a:off x="0" y="0"/>
-          <a:ext cx="0" cy="0"/>
-          <a:chOff x="0" y="0"/>
-          <a:chExt cx="0" cy="0"/>
-        </a:xfrm>
-      </p:grpSpPr>
-      <p:sp>
-        <p:nvSpPr>
-          <p:cNvPr id="2" name="Slide Image Placeholder 1"/>
-          <p:cNvSpPr>
-            <a:spLocks noGrp="1"/>
-          </p:cNvSpPr>
-          <p:nvPr>
-            <p:ph type="sldImg" idx="2"/>
-          </p:nvPr>
-        </p:nvSpPr>
-        <p:spPr/>
-      </p:sp>
-      <p:sp>
-        <p:nvSpPr>
-          <p:cNvPr id="3" name="Notes Placeholder 2"/>
-          <p:cNvSpPr>
-            <a:spLocks noGrp="1"/>
-          </p:cNvSpPr>
-          <p:nvPr>
-            <p:ph type="body" idx="3" sz="quarter"/>
-          </p:nvPr>
-        </p:nvSpPr>
-        <p:spPr/>
-        <p:txBody>
-          <a:bodyPr/>
-          <a:lstStyle/>
-          <a:p>
-            <a:r>
-              <a:t>Setiap rumus yang kita pakai hanya pendekatan. Galat pemotongan muncul karena suku dibuang. Orde O(h), O(h²), O(h⁴) menunjukkan kecepatan galat mengecil.</a:t>
-            </a:r>
-          </a:p>
-        </p:txBody>
-      </p:sp>
-      <p:sp>
-        <p:nvSpPr>
-          <p:cNvPr id="4" name="Slide Number Placeholder 3"/>
-          <p:cNvSpPr>
-            <a:spLocks noGrp="1"/>
-          </p:cNvSpPr>
-          <p:nvPr>
-            <p:ph type="sldNum" idx="5" sz="quarter"/>
-          </p:nvPr>
-        </p:nvSpPr>
-        <p:spPr/>
-      </p:sp>
-    </p:spTree>
-  </p:cSld>
-  <p:clrMapOvr>
-    <a:masterClrMapping/>
-  </p:clrMapOvr>
-</p:notes>
 </file>
 
 <file path=ppt/slideLayouts/slideLayout1.xml><?xml version="1.0" encoding="utf-8"?>
@@ -5047,7 +3227,7 @@
               </a:defRPr>
             </a:pPr>
             <a:r>
-              <a:t>METODE NUMERIK — BAB 6</a:t>
+              <a:t>METODE NUMERIK</a:t>
             </a:r>
           </a:p>
           <a:p>
@@ -5087,8 +3267,8 @@
         </p:nvSpPr>
         <p:spPr>
           <a:xfrm>
-            <a:off x="1371600" y="3931920"/>
-            <a:ext cx="7772400" cy="1645920"/>
+            <a:off x="1371600" y="3749039"/>
+            <a:ext cx="8412480" cy="2286000"/>
           </a:xfrm>
           <a:prstGeom prst="roundRect">
             <a:avLst/>
@@ -5122,32 +3302,62 @@
           <a:p>
             <a:pPr algn="ctr">
               <a:spcAft>
-                <a:spcPts val="600"/>
-              </a:spcAft>
-              <a:defRPr sz="1300" b="1">
+                <a:spcPts val="300"/>
+              </a:spcAft>
+              <a:defRPr sz="1100" b="1">
+                <a:solidFill>
+                  <a:srgbClr val="1E3A8A"/>
+                </a:solidFill>
+              </a:defRPr>
+            </a:pPr>
+            <a:r>
+              <a:t>ANGGOTA KELOMPOK:</a:t>
+            </a:r>
+          </a:p>
+          <a:p>
+            <a:pPr>
+              <a:spcAft>
+                <a:spcPts val="800"/>
+              </a:spcAft>
+              <a:defRPr sz="1200">
                 <a:solidFill>
                   <a:srgbClr val="0F172A"/>
                 </a:solidFill>
               </a:defRPr>
             </a:pPr>
             <a:r>
-              <a:t>Penyusun: [Nama Anggota Kelompok]    |    Dosen: [Nama Dosen]</a:t>
-            </a:r>
-          </a:p>
-          <a:p>
-            <a:pPr>
-              <a:defRPr sz="1200">
-                <a:solidFill>
-                  <a:srgbClr val="475569"/>
-                </a:solidFill>
-              </a:defRPr>
-            </a:pPr>
-            <a:r>
-              <a:t>Program Studi / Universitas: [Program Studi, Universitas]</a:t>
+              <a:t>1. Farel Luther Siagian (4253250041)       2. Fatih Taqiyyuddin (4253250057)</a:t>
             </a:r>
             <a:br/>
             <a:r>
-              <a:t>Tahun Akademik: 2026</a:t>
+              <a:t>3. Siti Zulayka Maulida Amali (4253250001)   4. Keegan Gibran Jehian (4253250029)</a:t>
+            </a:r>
+          </a:p>
+          <a:p>
+            <a:pPr>
+              <a:spcAft>
+                <a:spcPts val="200"/>
+              </a:spcAft>
+              <a:defRPr sz="1100" b="1">
+                <a:solidFill>
+                  <a:srgbClr val="1E3A8A"/>
+                </a:solidFill>
+              </a:defRPr>
+            </a:pPr>
+            <a:r>
+              <a:t>DOSEN PENGAMPU:</a:t>
+            </a:r>
+          </a:p>
+          <a:p>
+            <a:pPr>
+              <a:defRPr sz="1200" b="1">
+                <a:solidFill>
+                  <a:srgbClr val="0F172A"/>
+                </a:solidFill>
+              </a:defRPr>
+            </a:pPr>
+            <a:r>
+              <a:t>Debi Yandra Niska, S.Kom., M.Kom.    |    Tahun: 2026</a:t>
             </a:r>
           </a:p>
         </p:txBody>
@@ -6794,7 +5004,7 @@
               </a:defRPr>
             </a:pPr>
             <a:r>
-              <a:t>6.2 · EKSTRAPOLASI RICHARDSON</a:t>
+              <a:t>EKSTRAPOLASI RICHARDSON</a:t>
             </a:r>
           </a:p>
           <a:p>
@@ -13290,7 +11500,7 @@
               </a:defRPr>
             </a:pPr>
             <a:r>
-              <a:t>Catatan</a:t>
+              <a:t>Keterangan</a:t>
             </a:r>
           </a:p>
           <a:p>
@@ -13404,7 +11614,7 @@
               </a:defRPr>
             </a:pPr>
             <a:r>
-              <a:t>6 · PENGANTAR</a:t>
+              <a:t>PENGANTAR</a:t>
             </a:r>
           </a:p>
           <a:p>
@@ -13961,7 +12171,7 @@
               </a:defRPr>
             </a:pPr>
             <a:r>
-              <a:t>CONTOH MOTIVASI FISIKA (BUKU HLM. 185)</a:t>
+              <a:t>CONTOH MOTIVASI FISIKA (HLM. 185)</a:t>
             </a:r>
           </a:p>
           <a:p>
@@ -15330,7 +13540,7 @@
               </a:defRPr>
             </a:pPr>
             <a:r>
-              <a:t>•  Catatan: Data nyata tidak memiliki rumus fungsi kontinu eksak!</a:t>
+              <a:t>•  Data nyata tidak memiliki rumus fungsi kontinu eksak!</a:t>
             </a:r>
           </a:p>
         </p:txBody>
@@ -15602,7 +13812,7 @@
               </a:defRPr>
             </a:pPr>
             <a:r>
-              <a:t>6.1 · PENDEKATAN DERET</a:t>
+              <a:t>PENDEKATAN DERET</a:t>
             </a:r>
           </a:p>
           <a:p>
@@ -16187,7 +14397,7 @@
               </a:defRPr>
             </a:pPr>
             <a:r>
-              <a:t>6.1 · PENDEKATAN DERET</a:t>
+              <a:t>PENDEKATAN DERET</a:t>
             </a:r>
           </a:p>
           <a:p>
@@ -16724,7 +14934,7 @@
               </a:defRPr>
             </a:pPr>
             <a:r>
-              <a:t>6.1 · PENDEKATAN DERET</a:t>
+              <a:t>PENDEKATAN DERET</a:t>
             </a:r>
           </a:p>
           <a:p>
@@ -17279,7 +15489,7 @@
               </a:defRPr>
             </a:pPr>
             <a:r>
-              <a:t>6.1 · PENDEKATAN DERET</a:t>
+              <a:t>PENDEKATAN DERET</a:t>
             </a:r>
           </a:p>
           <a:p>
@@ -18889,7 +17099,7 @@
               </a:defRPr>
             </a:pPr>
             <a:r>
-              <a:t>Catatan</a:t>
+              <a:t>Keterangan</a:t>
             </a:r>
           </a:p>
           <a:p>
@@ -19439,7 +17649,7 @@
               </a:defRPr>
             </a:pPr>
             <a:r>
-              <a:t>•  Catatan: Notasi Big-O adalah perilaku asimtotik saat h cukup kecil.</a:t>
+              <a:t>•  Notasi Big-O adalah perilaku asimtotik saat h cukup kecil.</a:t>
             </a:r>
           </a:p>
         </p:txBody>
@@ -19770,324 +17980,4 @@
   </a:objectDefaults>
   <a:extraClrSchemeLst/>
 </a:theme>
-</file>
-
-<file path=ppt/theme/theme2.xml><?xml version="1.0" encoding="utf-8"?>
-<a:theme xmlns:a="http://schemas.openxmlformats.org/drawingml/2006/main" name="Office Theme">
-  <a:themeElements>
-    <a:clrScheme name="Office">
-      <a:dk1>
-        <a:sysClr val="windowText" lastClr="000000"/>
-      </a:dk1>
-      <a:lt1>
-        <a:sysClr val="window" lastClr="FFFFFF"/>
-      </a:lt1>
-      <a:dk2>
-        <a:srgbClr val="1F497D"/>
-      </a:dk2>
-      <a:lt2>
-        <a:srgbClr val="EEECE1"/>
-      </a:lt2>
-      <a:accent1>
-        <a:srgbClr val="4F81BD"/>
-      </a:accent1>
-      <a:accent2>
-        <a:srgbClr val="C0504D"/>
-      </a:accent2>
-      <a:accent3>
-        <a:srgbClr val="9BBB59"/>
-      </a:accent3>
-      <a:accent4>
-        <a:srgbClr val="8064A2"/>
-      </a:accent4>
-      <a:accent5>
-        <a:srgbClr val="4BACC6"/>
-      </a:accent5>
-      <a:accent6>
-        <a:srgbClr val="F79646"/>
-      </a:accent6>
-      <a:hlink>
-        <a:srgbClr val="0000FF"/>
-      </a:hlink>
-      <a:folHlink>
-        <a:srgbClr val="800080"/>
-      </a:folHlink>
-    </a:clrScheme>
-    <a:fontScheme name="Office">
-      <a:majorFont>
-        <a:latin typeface="Calibri"/>
-        <a:ea typeface=""/>
-        <a:cs typeface=""/>
-        <a:font script="Jpan" typeface="ＭＳ Ｐゴシック"/>
-        <a:font script="Hang" typeface="맑은 고딕"/>
-        <a:font script="Hans" typeface="宋体"/>
-        <a:font script="Hant" typeface="新細明體"/>
-        <a:font script="Arab" typeface="Times New Roman"/>
-        <a:font script="Hebr" typeface="Times New Roman"/>
-        <a:font script="Thai" typeface="Angsana New"/>
-        <a:font script="Ethi" typeface="Nyala"/>
-        <a:font script="Beng" typeface="Vrinda"/>
-        <a:font script="Gujr" typeface="Shruti"/>
-        <a:font script="Khmr" typeface="MoolBoran"/>
-        <a:font script="Knda" typeface="Tunga"/>
-        <a:font script="Guru" typeface="Raavi"/>
-        <a:font script="Cans" typeface="Euphemia"/>
-        <a:font script="Cher" typeface="Plantagenet Cherokee"/>
-        <a:font script="Yiii" typeface="Microsoft Yi Baiti"/>
-        <a:font script="Tibt" typeface="Microsoft Himalaya"/>
-        <a:font script="Thaa" typeface="MV Boli"/>
-        <a:font script="Deva" typeface="Mangal"/>
-        <a:font script="Telu" typeface="Gautami"/>
-        <a:font script="Taml" typeface="Latha"/>
-        <a:font script="Syrc" typeface="Estrangelo Edessa"/>
-        <a:font script="Orya" typeface="Kalinga"/>
-        <a:font script="Mlym" typeface="Kartika"/>
-        <a:font script="Laoo" typeface="DokChampa"/>
-        <a:font script="Sinh" typeface="Iskoola Pota"/>
-        <a:font script="Mong" typeface="Mongolian Baiti"/>
-        <a:font script="Viet" typeface="Times New Roman"/>
-        <a:font script="Uigh" typeface="Microsoft Uighur"/>
-        <a:font script="Geor" typeface="Sylfaen"/>
-      </a:majorFont>
-      <a:minorFont>
-        <a:latin typeface="Calibri"/>
-        <a:ea typeface=""/>
-        <a:cs typeface=""/>
-        <a:font script="Jpan" typeface="ＭＳ Ｐゴシック"/>
-        <a:font script="Hang" typeface="맑은 고딕"/>
-        <a:font script="Hans" typeface="宋体"/>
-        <a:font script="Hant" typeface="新細明體"/>
-        <a:font script="Arab" typeface="Arial"/>
-        <a:font script="Hebr" typeface="Arial"/>
-        <a:font script="Thai" typeface="Cordia New"/>
-        <a:font script="Ethi" typeface="Nyala"/>
-        <a:font script="Beng" typeface="Vrinda"/>
-        <a:font script="Gujr" typeface="Shruti"/>
-        <a:font script="Khmr" typeface="DaunPenh"/>
-        <a:font script="Knda" typeface="Tunga"/>
-        <a:font script="Guru" typeface="Raavi"/>
-        <a:font script="Cans" typeface="Euphemia"/>
-        <a:font script="Cher" typeface="Plantagenet Cherokee"/>
-        <a:font script="Yiii" typeface="Microsoft Yi Baiti"/>
-        <a:font script="Tibt" typeface="Microsoft Himalaya"/>
-        <a:font script="Thaa" typeface="MV Boli"/>
-        <a:font script="Deva" typeface="Mangal"/>
-        <a:font script="Telu" typeface="Gautami"/>
-        <a:font script="Taml" typeface="Latha"/>
-        <a:font script="Syrc" typeface="Estrangelo Edessa"/>
-        <a:font script="Orya" typeface="Kalinga"/>
-        <a:font script="Mlym" typeface="Kartika"/>
-        <a:font script="Laoo" typeface="DokChampa"/>
-        <a:font script="Sinh" typeface="Iskoola Pota"/>
-        <a:font script="Mong" typeface="Mongolian Baiti"/>
-        <a:font script="Viet" typeface="Arial"/>
-        <a:font script="Uigh" typeface="Microsoft Uighur"/>
-        <a:font script="Geor" typeface="Sylfaen"/>
-      </a:minorFont>
-    </a:fontScheme>
-    <a:fmtScheme name="Office">
-      <a:fillStyleLst>
-        <a:solidFill>
-          <a:schemeClr val="phClr"/>
-        </a:solidFill>
-        <a:gradFill rotWithShape="1">
-          <a:gsLst>
-            <a:gs pos="0">
-              <a:schemeClr val="phClr">
-                <a:tint val="50000"/>
-                <a:satMod val="300000"/>
-              </a:schemeClr>
-            </a:gs>
-            <a:gs pos="35000">
-              <a:schemeClr val="phClr">
-                <a:tint val="37000"/>
-                <a:satMod val="300000"/>
-              </a:schemeClr>
-            </a:gs>
-            <a:gs pos="100000">
-              <a:schemeClr val="phClr">
-                <a:tint val="15000"/>
-                <a:satMod val="350000"/>
-              </a:schemeClr>
-            </a:gs>
-          </a:gsLst>
-          <a:lin ang="16200000" scaled="1"/>
-        </a:gradFill>
-        <a:gradFill rotWithShape="1">
-          <a:gsLst>
-            <a:gs pos="0">
-              <a:schemeClr val="phClr">
-                <a:tint val="100000"/>
-                <a:shade val="100000"/>
-                <a:satMod val="130000"/>
-              </a:schemeClr>
-            </a:gs>
-            <a:gs pos="100000">
-              <a:schemeClr val="phClr">
-                <a:tint val="50000"/>
-                <a:shade val="100000"/>
-                <a:satMod val="350000"/>
-              </a:schemeClr>
-            </a:gs>
-          </a:gsLst>
-          <a:lin ang="16200000" scaled="0"/>
-        </a:gradFill>
-      </a:fillStyleLst>
-      <a:lnStyleLst>
-        <a:ln w="9525" cap="flat" cmpd="sng" algn="ctr">
-          <a:solidFill>
-            <a:schemeClr val="phClr">
-              <a:shade val="95000"/>
-              <a:satMod val="105000"/>
-            </a:schemeClr>
-          </a:solidFill>
-          <a:prstDash val="solid"/>
-        </a:ln>
-        <a:ln w="25400" cap="flat" cmpd="sng" algn="ctr">
-          <a:solidFill>
-            <a:schemeClr val="phClr"/>
-          </a:solidFill>
-          <a:prstDash val="solid"/>
-        </a:ln>
-        <a:ln w="38100" cap="flat" cmpd="sng" algn="ctr">
-          <a:solidFill>
-            <a:schemeClr val="phClr"/>
-          </a:solidFill>
-          <a:prstDash val="solid"/>
-        </a:ln>
-      </a:lnStyleLst>
-      <a:effectStyleLst>
-        <a:effectStyle>
-          <a:effectLst>
-            <a:outerShdw blurRad="40000" dist="20000" dir="5400000" rotWithShape="0">
-              <a:srgbClr val="000000">
-                <a:alpha val="38000"/>
-              </a:srgbClr>
-            </a:outerShdw>
-          </a:effectLst>
-        </a:effectStyle>
-        <a:effectStyle>
-          <a:effectLst>
-            <a:outerShdw blurRad="40000" dist="23000" dir="5400000" rotWithShape="0">
-              <a:srgbClr val="000000">
-                <a:alpha val="35000"/>
-              </a:srgbClr>
-            </a:outerShdw>
-          </a:effectLst>
-        </a:effectStyle>
-        <a:effectStyle>
-          <a:effectLst>
-            <a:outerShdw blurRad="40000" dist="23000" dir="5400000" rotWithShape="0">
-              <a:srgbClr val="000000">
-                <a:alpha val="35000"/>
-              </a:srgbClr>
-            </a:outerShdw>
-          </a:effectLst>
-          <a:scene3d>
-            <a:camera prst="orthographicFront">
-              <a:rot lat="0" lon="0" rev="0"/>
-            </a:camera>
-            <a:lightRig rig="threePt" dir="t">
-              <a:rot lat="0" lon="0" rev="1200000"/>
-            </a:lightRig>
-          </a:scene3d>
-          <a:sp3d>
-            <a:bevelT w="63500" h="25400"/>
-          </a:sp3d>
-        </a:effectStyle>
-      </a:effectStyleLst>
-      <a:bgFillStyleLst>
-        <a:solidFill>
-          <a:schemeClr val="phClr"/>
-        </a:solidFill>
-        <a:gradFill rotWithShape="1">
-          <a:gsLst>
-            <a:gs pos="0">
-              <a:schemeClr val="phClr">
-                <a:tint val="40000"/>
-                <a:satMod val="350000"/>
-              </a:schemeClr>
-            </a:gs>
-            <a:gs pos="40000">
-              <a:schemeClr val="phClr">
-                <a:tint val="45000"/>
-                <a:shade val="99000"/>
-                <a:satMod val="350000"/>
-              </a:schemeClr>
-            </a:gs>
-            <a:gs pos="100000">
-              <a:schemeClr val="phClr">
-                <a:shade val="20000"/>
-                <a:satMod val="255000"/>
-              </a:schemeClr>
-            </a:gs>
-          </a:gsLst>
-          <a:path path="circle">
-            <a:fillToRect l="50000" t="-80000" r="50000" b="180000"/>
-          </a:path>
-        </a:gradFill>
-        <a:gradFill rotWithShape="1">
-          <a:gsLst>
-            <a:gs pos="0">
-              <a:schemeClr val="phClr">
-                <a:tint val="80000"/>
-                <a:satMod val="300000"/>
-              </a:schemeClr>
-            </a:gs>
-            <a:gs pos="100000">
-              <a:schemeClr val="phClr">
-                <a:shade val="30000"/>
-                <a:satMod val="200000"/>
-              </a:schemeClr>
-            </a:gs>
-          </a:gsLst>
-          <a:path path="circle">
-            <a:fillToRect l="50000" t="50000" r="50000" b="50000"/>
-          </a:path>
-        </a:gradFill>
-      </a:bgFillStyleLst>
-    </a:fmtScheme>
-  </a:themeElements>
-  <a:objectDefaults>
-    <a:spDef>
-      <a:spPr/>
-      <a:bodyPr/>
-      <a:lstStyle/>
-      <a:style>
-        <a:lnRef idx="1">
-          <a:schemeClr val="accent1"/>
-        </a:lnRef>
-        <a:fillRef idx="3">
-          <a:schemeClr val="accent1"/>
-        </a:fillRef>
-        <a:effectRef idx="2">
-          <a:schemeClr val="accent1"/>
-        </a:effectRef>
-        <a:fontRef idx="minor">
-          <a:schemeClr val="lt1"/>
-        </a:fontRef>
-      </a:style>
-    </a:spDef>
-    <a:lnDef>
-      <a:spPr/>
-      <a:bodyPr/>
-      <a:lstStyle/>
-      <a:style>
-        <a:lnRef idx="2">
-          <a:schemeClr val="accent1"/>
-        </a:lnRef>
-        <a:fillRef idx="0">
-          <a:schemeClr val="accent1"/>
-        </a:fillRef>
-        <a:effectRef idx="1">
-          <a:schemeClr val="accent1"/>
-        </a:effectRef>
-        <a:fontRef idx="minor">
-          <a:schemeClr val="tx1"/>
-        </a:fontRef>
-      </a:style>
-    </a:lnDef>
-  </a:objectDefaults>
-  <a:extraClrSchemeLst/>
-</a:theme>
 </file>
</xml_diff>